<commit_message>
trust: measured injection red-team, honest text claims
- real ollama:llama3.1:8b run: 0/90 bands lowered (structural), 41/88 echoed before checker, 32/41 rejected, 9/88 survived, 2 timeouts
- docs/deck now distinguish structural 0 from model accuracy; lead with the floor (17/17 payee changes)
- text-classifier limits (leave-one-dataset-out 0.69-0.99, P 61.2 / R 39.4, 12.1% benign false ask) stated for judges
- tests: make check green (884 passed, 16 skipped)
</commit_message>
<xml_diff>
--- a/Satyapan_Pitch_Deck.pptx
+++ b/Satyapan_Pitch_Deck.pptx
@@ -655,7 +655,7 @@
           <a:lstStyle/>
           <a:p>
             <a:r>
-              <a:t>Our work is backed by rigorous empirical benchmarks. On Google Meet codecs, our voice detector achieves 0.0% Equal Error Rate. In adversarial testing, 0 out of 30 prompt injections bypassed our policy. On 31,000 ICFD conversations, we achieve over 94% recall at 1% false alarms.</a:t>
+              <a:t>Our work is backed by empirical benchmarks with named limits. On speaker-disjoint In-the-Wild audio under Opus 16 kbps, the voice check reaches AUC 0.909 and EER 16.9%; this is public data, not a Meet-calibrated number. In the injection red-team, 0/90 bands were lowered — that is structural. The local llama3.1:8b echoed 41/88 successful calls; the checker rejected 32 of those 41, and 9/88 final summaries still echoed (2 timeouts). The band is never read from model text; the residual is misleading prose, which is why the template fallback is authoritative. On 31,000 ICFD conversations, the research detector reaches over 94% recall at 1% false alarms; that is the research claim, not the product's.</a:t>
             </a:r>
           </a:p>
         </p:txBody>
@@ -1285,7 +1285,7 @@
           <a:lstStyle/>
           <a:p>
             <a:r>
-              <a:t>Layer 3 is the mathematical brain. There are three bands: PASS, VERIFY, and HOLD. Any bank change forces at least VERIFY. Strong anomalies force HOLD. Generative LLMs have zero ability to alter these bands, making the engine completely prompt-injection proof.</a:t>
+              <a:t>Layer 3 is the mathematical brain. There are three bands: PASS, VERIFY, and HOLD. Any bank change forces at least VERIFY. Strong anomalies force HOLD. The band is computed before any summary and is never parsed from model text, so a prompt injection can make the prose wrong but cannot change the decision.</a:t>
             </a:r>
           </a:p>
         </p:txBody>
@@ -5869,7 +5869,7 @@
               </a:defRPr>
             </a:pPr>
             <a:r>
-              <a:t>0.0% EER</a:t>
+              <a:t>0.909 AUC</a:t>
             </a:r>
           </a:p>
           <a:p>
@@ -5882,11 +5882,11 @@
               </a:defRPr>
             </a:pPr>
             <a:r>
-              <a:t>Google Meet Codec</a:t>
+              <a:t>In-the-Wild voice</a:t>
             </a:r>
             <a:br/>
             <a:r>
-              <a:t>(Opus 16kHz audio)</a:t>
+              <a:t>(Opus 16 kbps)</a:t>
             </a:r>
           </a:p>
           <a:p>
@@ -5899,7 +5899,7 @@
               </a:defRPr>
             </a:pPr>
             <a:r>
-              <a:t>Zero error rate on WebRTC video call audio (n=100 items). 4.0% EER on cellular AMR-NB.</a:t>
+              <a:t>Speaker-disjoint public deepfakes: AUC 0.909 [0.857, 0.948], EER 16.9%; 58.3% of fakes flagged at tau_lo, 1.8% of genuine voices flagged. Not a Meet-calibrated number.</a:t>
             </a:r>
           </a:p>
         </p:txBody>
@@ -5979,7 +5979,7 @@
               </a:defRPr>
             </a:pPr>
             <a:r>
-              <a:t>0 / 30 Bypassed</a:t>
+              <a:t>0 / 90 Bands Lowered</a:t>
             </a:r>
           </a:p>
           <a:p>
@@ -6009,7 +6009,7 @@
               </a:defRPr>
             </a:pPr>
             <a:r>
-              <a:t>0/30 injections lowered a security band. 97.8% checker rejection rate on malicious prompts.</a:t>
+              <a:t>30 samples x 3 cases; 0 lowered is structural. Local model (ollama:llama3.1:8b) echoed 41/88 successful calls; checker rejected 32/41 echoes; 9/88 final summaries still echoed.</a:t>
             </a:r>
           </a:p>
         </p:txBody>
@@ -6229,7 +6229,7 @@
               </a:defRPr>
             </a:pPr>
             <a:r>
-              <a:t>Detectors upgraded risk outcome from unsafe PASS to HOLD/VERIFY in 8 out of 12 real attack cases.</a:t>
+              <a:t>Detectors changed the rules-only outcome in 8 of 12 team-authored scenarios (illustrative, not a detection result).</a:t>
             </a:r>
           </a:p>
         </p:txBody>
@@ -9836,7 +9836,7 @@
               </a:defRPr>
             </a:pPr>
             <a:r>
-              <a:t>🛡️ Prompt-Injection Immunity:</a:t>
+              <a:t>🛡️ Prompt-Injection Containment:</a:t>
             </a:r>
           </a:p>
           <a:p>
@@ -9844,7 +9844,7 @@
               <a:defRPr sz="1100"/>
             </a:pPr>
             <a:r>
-              <a:t>LLMs are restricted to text summarization only and have ZERO write access to security bands. 30/30 red-team prompt injections failed to bypass this engine.</a:t>
+              <a:t>LLMs are restricted to text summarization only and have ZERO write access to security bands. 30 injection samples x 3 cases: 0/90 bands lowered (structural). Local model (ollama:llama3.1:8b) echoed 41/88 successful calls; checker rejected 32/41 echoes; 9/88 final summaries still echoed. Overall checker rejection 69.3%.</a:t>
             </a:r>
           </a:p>
         </p:txBody>

</xml_diff>